<commit_message>
fix(prod): auto-provision secure JWT key for Render/PaaS, add clickable citations and HD architecture diagram, remove references [21]-[25], and polish presentation with Canva-style design
</commit_message>
<xml_diff>
--- a/docs/QuantumGuard_Project_Presentation_15.pptx
+++ b/docs/QuantumGuard_Project_Presentation_15.pptx
@@ -3335,6 +3335,84 @@
           </a:p>
         </p:txBody>
       </p:sp>
+      <p:sp>
+        <p:nvSpPr>
+          <p:cNvPr id="26" name="Rounded Rectangle 25"/>
+          <p:cNvSpPr/>
+          <p:nvPr/>
+        </p:nvSpPr>
+        <p:spPr>
+          <a:xfrm>
+            <a:off x="6217920" y="4389120"/>
+            <a:ext cx="2468880" cy="1645920"/>
+          </a:xfrm>
+          <a:prstGeom prst="roundRect">
+            <a:avLst/>
+          </a:prstGeom>
+          <a:solidFill>
+            <a:srgbClr val="141A2A"/>
+          </a:solidFill>
+          <a:ln w="19050">
+            <a:solidFill>
+              <a:srgbClr val="A855F7"/>
+            </a:solidFill>
+          </a:ln>
+        </p:spPr>
+        <p:style>
+          <a:lnRef idx="1">
+            <a:schemeClr val="accent1"/>
+          </a:lnRef>
+          <a:fillRef idx="3">
+            <a:schemeClr val="accent1"/>
+          </a:fillRef>
+          <a:effectRef idx="2">
+            <a:schemeClr val="accent1"/>
+          </a:effectRef>
+          <a:fontRef idx="minor">
+            <a:schemeClr val="lt1"/>
+          </a:fontRef>
+        </p:style>
+        <p:txBody>
+          <a:bodyPr rtlCol="0" anchor="ctr" wrap="square"/>
+          <a:lstStyle/>
+          <a:p>
+            <a:pPr algn="ctr">
+              <a:defRPr b="1" sz="1100">
+                <a:solidFill>
+                  <a:srgbClr val="A855F7"/>
+                </a:solidFill>
+              </a:defRPr>
+            </a:pPr>
+            <a:r>
+              <a:t>Empirical Benchmark</a:t>
+            </a:r>
+          </a:p>
+          <a:p>
+            <a:pPr>
+              <a:defRPr sz="900">
+                <a:solidFill>
+                  <a:srgbClr val="F1F5F9"/>
+                </a:solidFill>
+              </a:defRPr>
+            </a:pPr>
+            <a:r>
+              <a:t>• S = 2.819 +/- 0.014</a:t>
+            </a:r>
+            <a:br/>
+            <a:r>
+              <a:t>• 4,096 Shots / angle</a:t>
+            </a:r>
+            <a:br/>
+            <a:r>
+              <a:t>• Classical limit: 2.0</a:t>
+            </a:r>
+            <a:br/>
+            <a:r>
+              <a:t>• Non-locality confirmed</a:t>
+            </a:r>
+          </a:p>
+        </p:txBody>
+      </p:sp>
     </p:spTree>
   </p:cSld>
   <p:clrMapOvr>
@@ -4413,6 +4491,84 @@
               <a:t>11</a:t>
             </a:fld>
             <a:endParaRPr lang="en-US"/>
+          </a:p>
+        </p:txBody>
+      </p:sp>
+      <p:sp>
+        <p:nvSpPr>
+          <p:cNvPr id="35" name="Rounded Rectangle 34"/>
+          <p:cNvSpPr/>
+          <p:nvPr/>
+        </p:nvSpPr>
+        <p:spPr>
+          <a:xfrm>
+            <a:off x="6217920" y="4389120"/>
+            <a:ext cx="2468880" cy="1645920"/>
+          </a:xfrm>
+          <a:prstGeom prst="roundRect">
+            <a:avLst/>
+          </a:prstGeom>
+          <a:solidFill>
+            <a:srgbClr val="0F1E18"/>
+          </a:solidFill>
+          <a:ln w="19050">
+            <a:solidFill>
+              <a:srgbClr val="10B981"/>
+            </a:solidFill>
+          </a:ln>
+        </p:spPr>
+        <p:style>
+          <a:lnRef idx="1">
+            <a:schemeClr val="accent1"/>
+          </a:lnRef>
+          <a:fillRef idx="3">
+            <a:schemeClr val="accent1"/>
+          </a:fillRef>
+          <a:effectRef idx="2">
+            <a:schemeClr val="accent1"/>
+          </a:effectRef>
+          <a:fontRef idx="minor">
+            <a:schemeClr val="lt1"/>
+          </a:fontRef>
+        </p:style>
+        <p:txBody>
+          <a:bodyPr rtlCol="0" anchor="ctr" wrap="square"/>
+          <a:lstStyle/>
+          <a:p>
+            <a:pPr algn="ctr">
+              <a:defRPr b="1" sz="1100">
+                <a:solidFill>
+                  <a:srgbClr val="34D399"/>
+                </a:solidFill>
+              </a:defRPr>
+            </a:pPr>
+            <a:r>
+              <a:t>Defense Verification</a:t>
+            </a:r>
+          </a:p>
+          <a:p>
+            <a:pPr>
+              <a:defRPr sz="900">
+                <a:solidFill>
+                  <a:srgbClr val="F1F5F9"/>
+                </a:solidFill>
+              </a:defRPr>
+            </a:pPr>
+            <a:r>
+              <a:t>• QBER: 25.18% +/- 1.84%</a:t>
+            </a:r>
+            <a:br/>
+            <a:r>
+              <a:t>• 95% Wilson Confidence</a:t>
+            </a:r>
+            <a:br/>
+            <a:r>
+              <a:t>• Abort Threshold: 11%</a:t>
+            </a:r>
+            <a:br/>
+            <a:r>
+              <a:t>• Eve Intercept: 100% Caught</a:t>
+            </a:r>
           </a:p>
         </p:txBody>
       </p:sp>
@@ -10647,6 +10803,72 @@
           </a:p>
         </p:txBody>
       </p:sp>
+      <p:sp>
+        <p:nvSpPr>
+          <p:cNvPr id="30" name="Rounded Rectangle 29"/>
+          <p:cNvSpPr/>
+          <p:nvPr/>
+        </p:nvSpPr>
+        <p:spPr>
+          <a:xfrm>
+            <a:off x="731520" y="5577840"/>
+            <a:ext cx="7680960" cy="822960"/>
+          </a:xfrm>
+          <a:prstGeom prst="roundRect">
+            <a:avLst/>
+          </a:prstGeom>
+          <a:solidFill>
+            <a:srgbClr val="182036"/>
+          </a:solidFill>
+          <a:ln w="19050">
+            <a:solidFill>
+              <a:srgbClr val="38BDF8"/>
+            </a:solidFill>
+          </a:ln>
+        </p:spPr>
+        <p:style>
+          <a:lnRef idx="1">
+            <a:schemeClr val="accent1"/>
+          </a:lnRef>
+          <a:fillRef idx="3">
+            <a:schemeClr val="accent1"/>
+          </a:fillRef>
+          <a:effectRef idx="2">
+            <a:schemeClr val="accent1"/>
+          </a:effectRef>
+          <a:fontRef idx="minor">
+            <a:schemeClr val="lt1"/>
+          </a:fontRef>
+        </p:style>
+        <p:txBody>
+          <a:bodyPr rtlCol="0" anchor="ctr" wrap="square"/>
+          <a:lstStyle/>
+          <a:p>
+            <a:pPr algn="ctr">
+              <a:defRPr sz="1100" b="1">
+                <a:solidFill>
+                  <a:srgbClr val="38BDF8"/>
+                </a:solidFill>
+              </a:defRPr>
+            </a:pPr>
+            <a:r>
+              <a:t>Practical Engineering Highlight: Zero-Knowledge Credential Sanitization</a:t>
+            </a:r>
+          </a:p>
+          <a:p>
+            <a:pPr>
+              <a:defRPr sz="950">
+                <a:solidFill>
+                  <a:srgbClr val="E2E8F0"/>
+                </a:solidFill>
+              </a:defRPr>
+            </a:pPr>
+            <a:r>
+              <a:t>Raw adversary passwords and stolen auth tokens are immediately SHA-256 hashed before disk write or SSE streaming.</a:t>
+            </a:r>
+          </a:p>
+        </p:txBody>
+      </p:sp>
     </p:spTree>
   </p:cSld>
   <p:clrMapOvr>

</xml_diff>